<commit_message>
fix(pptx): handle unsupported 3-D chart types without crashing (#3972)
Signed-off-by: Cesar Berrospi Ramis <ceb@zurich.ibm.com>
</commit_message>
<xml_diff>
--- a/tests/data/pptx/sources/pptx_chart.pptx
+++ b/tests/data/pptx/sources/pptx_chart.pptx
@@ -5,7 +5,8 @@
     <p:sldMasterId id="2147483648" r:id="rId1"/>
   </p:sldMasterIdLst>
   <p:sldIdLst>
-    <p:sldId id="256" r:id="rId7"/>
+    <p:sldId id="256" r:id="rId2"/>
+    <p:sldId id="258" r:id="rId3"/>
   </p:sldIdLst>
   <p:sldSz cx="9144000" cy="6858000" type="screen4x3"/>
   <p:notesSz cx="6858000" cy="9144000"/>
@@ -104,12 +105,31 @@
       </a:defRPr>
     </a:lvl9pPr>
   </p:defaultTextStyle>
+  <p:extLst>
+    <p:ext uri="{EFAFB233-063F-42B5-8137-9DF3F51BA10A}">
+      <p15:sldGuideLst xmlns:p15="http://schemas.microsoft.com/office/powerpoint/2012/main">
+        <p15:guide id="1" orient="horz" pos="2160">
+          <p15:clr>
+            <a:srgbClr val="A4A3A4"/>
+          </p15:clr>
+        </p15:guide>
+        <p15:guide id="2" pos="2880">
+          <p15:clr>
+            <a:srgbClr val="A4A3A4"/>
+          </p15:clr>
+        </p15:guide>
+      </p15:sldGuideLst>
+    </p:ext>
+  </p:extLst>
 </p:presentation>
 </file>
 
 <file path=ppt/charts/chart1.xml><?xml version="1.0" encoding="utf-8"?>
-<c:chartSpace xmlns:c="http://schemas.openxmlformats.org/drawingml/2006/chart" xmlns:a="http://schemas.openxmlformats.org/drawingml/2006/main" xmlns:r="http://schemas.openxmlformats.org/officeDocument/2006/relationships">
+<c:chartSpace xmlns:c="http://schemas.openxmlformats.org/drawingml/2006/chart" xmlns:a="http://schemas.openxmlformats.org/drawingml/2006/main" xmlns:r="http://schemas.openxmlformats.org/officeDocument/2006/relationships" xmlns:c16r2="http://schemas.microsoft.com/office/drawing/2015/06/chart">
   <c:date1904 val="0"/>
+  <c:lang val="en-US"/>
+  <c:roundedCorners val="1"/>
+  <c:style val="2"/>
   <c:chart>
     <c:title>
       <c:tx>
@@ -118,19 +138,21 @@
           <a:lstStyle/>
           <a:p>
             <a:r>
+              <a:rPr lang="en-US"/>
               <a:t>Wild Duck Observations by Year</a:t>
             </a:r>
           </a:p>
         </c:rich>
       </c:tx>
-      <c:layout/>
       <c:overlay val="0"/>
     </c:title>
     <c:autoTitleDeleted val="0"/>
     <c:plotArea>
+      <c:layout/>
       <c:barChart>
         <c:barDir val="col"/>
         <c:grouping val="clustered"/>
+        <c:varyColors val="1"/>
         <c:ser>
           <c:idx val="0"/>
           <c:order val="0"/>
@@ -145,6 +167,7 @@
               </c:strCache>
             </c:strRef>
           </c:tx>
+          <c:invertIfNegative val="1"/>
           <c:cat>
             <c:strRef>
               <c:f>Sheet1!$A$2:$A$5</c:f>
@@ -186,6 +209,11 @@
               </c:numCache>
             </c:numRef>
           </c:val>
+          <c:extLst>
+            <c:ext xmlns:c16="http://schemas.microsoft.com/office/drawing/2014/chart" uri="{C3380CC4-5D6E-409C-BE32-E72D297353CC}">
+              <c16:uniqueId val="{00000000-C2C8-4E40-930E-868C47C89073}"/>
+            </c:ext>
+          </c:extLst>
         </c:ser>
         <c:ser>
           <c:idx val="1"/>
@@ -201,6 +229,7 @@
               </c:strCache>
             </c:strRef>
           </c:tx>
+          <c:invertIfNegative val="1"/>
           <c:cat>
             <c:strRef>
               <c:f>Sheet1!$A$2:$A$5</c:f>
@@ -242,7 +271,21 @@
               </c:numCache>
             </c:numRef>
           </c:val>
+          <c:extLst>
+            <c:ext xmlns:c16="http://schemas.microsoft.com/office/drawing/2014/chart" uri="{C3380CC4-5D6E-409C-BE32-E72D297353CC}">
+              <c16:uniqueId val="{00000001-C2C8-4E40-930E-868C47C89073}"/>
+            </c:ext>
+          </c:extLst>
         </c:ser>
+        <c:dLbls>
+          <c:showLegendKey val="0"/>
+          <c:showVal val="0"/>
+          <c:showCatName val="0"/>
+          <c:showSerName val="0"/>
+          <c:showPercent val="0"/>
+          <c:showBubbleSize val="0"/>
+        </c:dLbls>
+        <c:gapWidth val="150"/>
         <c:axId val="-2068027336"/>
         <c:axId val="-2113994440"/>
       </c:barChart>
@@ -253,6 +296,7 @@
         </c:scaling>
         <c:delete val="0"/>
         <c:axPos val="b"/>
+        <c:numFmt formatCode="General" sourceLinked="0"/>
         <c:majorTickMark val="out"/>
         <c:minorTickMark val="none"/>
         <c:tickLblPos val="nextTo"/>
@@ -265,18 +309,180 @@
       </c:catAx>
       <c:valAx>
         <c:axId val="-2113994440"/>
-        <c:scaling/>
+        <c:scaling>
+          <c:orientation val="minMax"/>
+        </c:scaling>
         <c:delete val="0"/>
         <c:axPos val="l"/>
         <c:majorGridlines/>
+        <c:numFmt formatCode="General" sourceLinked="1"/>
         <c:majorTickMark val="out"/>
         <c:minorTickMark val="none"/>
         <c:tickLblPos val="nextTo"/>
         <c:crossAx val="-2068027336"/>
         <c:crosses val="autoZero"/>
+        <c:crossBetween val="between"/>
       </c:valAx>
     </c:plotArea>
+    <c:plotVisOnly val="1"/>
     <c:dispBlanksAs val="gap"/>
+    <c:showDLblsOverMax val="1"/>
+  </c:chart>
+  <c:txPr>
+    <a:bodyPr/>
+    <a:lstStyle/>
+    <a:p>
+      <a:pPr>
+        <a:defRPr sz="1800"/>
+      </a:pPr>
+      <a:endParaRPr lang="en-US"/>
+    </a:p>
+  </c:txPr>
+  <c:externalData r:id="rId1">
+    <c:autoUpdate val="0"/>
+  </c:externalData>
+</c:chartSpace>
+</file>
+
+<file path=ppt/charts/chart2.xml><?xml version="1.0" encoding="utf-8"?>
+<c:chartSpace xmlns:c="http://schemas.openxmlformats.org/drawingml/2006/chart" xmlns:a="http://schemas.openxmlformats.org/drawingml/2006/main" xmlns:r="http://schemas.openxmlformats.org/officeDocument/2006/relationships" xmlns:c16r2="http://schemas.microsoft.com/office/drawing/2015/06/chart">
+  <c:date1904 val="0"/>
+  <c:lang val="en-US"/>
+  <c:roundedCorners val="1"/>
+  <c:style val="2"/>
+  <c:chart>
+    <c:title>
+      <c:overlay val="0"/>
+    </c:title>
+    <c:autoTitleDeleted val="0"/>
+    <c:view3D>
+      <c:rotX val="15"/>
+      <c:rotY val="20"/>
+      <c:rAngAx val="0"/>
+    </c:view3D>
+    <c:floor>
+      <c:thickness val="0"/>
+    </c:floor>
+    <c:sideWall>
+      <c:thickness val="0"/>
+    </c:sideWall>
+    <c:backWall>
+      <c:thickness val="0"/>
+    </c:backWall>
+    <c:plotArea>
+      <c:layout/>
+      <c:bar3DChart>
+        <c:barDir val="col"/>
+        <c:grouping val="clustered"/>
+        <c:varyColors val="1"/>
+        <c:ser>
+          <c:idx val="0"/>
+          <c:order val="0"/>
+          <c:tx>
+            <c:strRef>
+              <c:f>Sheet1!$B$1</c:f>
+              <c:strCache>
+                <c:ptCount val="1"/>
+                <c:pt idx="0">
+                  <c:v>2026</c:v>
+                </c:pt>
+              </c:strCache>
+            </c:strRef>
+          </c:tx>
+          <c:invertIfNegative val="1"/>
+          <c:cat>
+            <c:strRef>
+              <c:f>Sheet1!$A$2:$A$4</c:f>
+              <c:strCache>
+                <c:ptCount val="3"/>
+                <c:pt idx="0">
+                  <c:v>Q1</c:v>
+                </c:pt>
+                <c:pt idx="1">
+                  <c:v>Q2</c:v>
+                </c:pt>
+                <c:pt idx="2">
+                  <c:v>Q3</c:v>
+                </c:pt>
+              </c:strCache>
+            </c:strRef>
+          </c:cat>
+          <c:val>
+            <c:numRef>
+              <c:f>Sheet1!$B$2:$B$4</c:f>
+              <c:numCache>
+                <c:formatCode>General</c:formatCode>
+                <c:ptCount val="3"/>
+                <c:pt idx="0">
+                  <c:v>10</c:v>
+                </c:pt>
+                <c:pt idx="1">
+                  <c:v>20</c:v>
+                </c:pt>
+                <c:pt idx="2">
+                  <c:v>30</c:v>
+                </c:pt>
+              </c:numCache>
+            </c:numRef>
+          </c:val>
+          <c:extLst>
+            <c:ext xmlns:c16="http://schemas.microsoft.com/office/drawing/2014/chart" uri="{C3380CC4-5D6E-409C-BE32-E72D297353CC}">
+              <c16:uniqueId val="{00000000-4D58-7242-AA41-CFAD0EE88EC6}"/>
+            </c:ext>
+          </c:extLst>
+        </c:ser>
+        <c:dLbls>
+          <c:showLegendKey val="0"/>
+          <c:showVal val="0"/>
+          <c:showCatName val="0"/>
+          <c:showSerName val="0"/>
+          <c:showPercent val="0"/>
+          <c:showBubbleSize val="0"/>
+        </c:dLbls>
+        <c:gapWidth val="150"/>
+        <c:shape val="box"/>
+        <c:axId val="-2068027336"/>
+        <c:axId val="-2113994440"/>
+        <c:axId val="0"/>
+      </c:bar3DChart>
+      <c:catAx>
+        <c:axId val="-2068027336"/>
+        <c:scaling>
+          <c:orientation val="minMax"/>
+        </c:scaling>
+        <c:delete val="0"/>
+        <c:axPos val="b"/>
+        <c:numFmt formatCode="General" sourceLinked="0"/>
+        <c:majorTickMark val="out"/>
+        <c:minorTickMark val="none"/>
+        <c:tickLblPos val="nextTo"/>
+        <c:crossAx val="-2113994440"/>
+        <c:crosses val="autoZero"/>
+        <c:auto val="1"/>
+        <c:lblAlgn val="ctr"/>
+        <c:lblOffset val="100"/>
+        <c:noMultiLvlLbl val="0"/>
+      </c:catAx>
+      <c:valAx>
+        <c:axId val="-2113994440"/>
+        <c:scaling>
+          <c:orientation val="minMax"/>
+        </c:scaling>
+        <c:delete val="0"/>
+        <c:axPos val="l"/>
+        <c:majorGridlines/>
+        <c:numFmt formatCode="General" sourceLinked="1"/>
+        <c:majorTickMark val="out"/>
+        <c:minorTickMark val="none"/>
+        <c:tickLblPos val="nextTo"/>
+        <c:crossAx val="-2068027336"/>
+        <c:crosses val="autoZero"/>
+        <c:crossBetween val="between"/>
+      </c:valAx>
+    </c:plotArea>
+    <c:plotVisOnly val="1"/>
+    <c:dispBlanksAs val="gap"/>
+    <c:showDLblsOverMax val="1"/>
   </c:chart>
   <c:txPr>
     <a:bodyPr/>
@@ -332,10 +538,9 @@
           <a:lstStyle/>
           <a:p>
             <a:r>
-              <a:rPr lang="en-US" smtClean="0"/>
+              <a:rPr lang="en-US"/>
               <a:t>Click to edit Master title style</a:t>
             </a:r>
-            <a:endParaRPr lang="en-US"/>
           </a:p>
         </p:txBody>
       </p:sp>
@@ -451,10 +656,9 @@
           </a:lstStyle>
           <a:p>
             <a:r>
-              <a:rPr lang="en-US" smtClean="0"/>
+              <a:rPr lang="en-US"/>
               <a:t>Click to edit Master subtitle style</a:t>
             </a:r>
-            <a:endParaRPr lang="en-US"/>
           </a:p>
         </p:txBody>
       </p:sp>
@@ -475,7 +679,7 @@
           <a:p>
             <a:fld id="{5BCAD085-E8A6-8845-BD4E-CB4CCA059FC4}" type="datetimeFigureOut">
               <a:rPr lang="en-US" smtClean="0"/>
-              <a:t>1/27/13</a:t>
+              <a:t>8/10/26</a:t>
             </a:fld>
             <a:endParaRPr lang="en-US"/>
           </a:p>
@@ -569,10 +773,9 @@
           <a:lstStyle/>
           <a:p>
             <a:r>
-              <a:rPr lang="en-US" smtClean="0"/>
+              <a:rPr lang="en-US"/>
               <a:t>Click to edit Master title style</a:t>
             </a:r>
-            <a:endParaRPr lang="en-US"/>
           </a:p>
         </p:txBody>
       </p:sp>
@@ -593,38 +796,37 @@
           <a:p>
             <a:pPr lvl="0"/>
             <a:r>
-              <a:rPr lang="en-US" smtClean="0"/>
+              <a:rPr lang="en-US"/>
               <a:t>Click to edit Master text styles</a:t>
             </a:r>
           </a:p>
           <a:p>
             <a:pPr lvl="1"/>
             <a:r>
-              <a:rPr lang="en-US" smtClean="0"/>
+              <a:rPr lang="en-US"/>
               <a:t>Second level</a:t>
             </a:r>
           </a:p>
           <a:p>
             <a:pPr lvl="2"/>
             <a:r>
-              <a:rPr lang="en-US" smtClean="0"/>
+              <a:rPr lang="en-US"/>
               <a:t>Third level</a:t>
             </a:r>
           </a:p>
           <a:p>
             <a:pPr lvl="3"/>
             <a:r>
-              <a:rPr lang="en-US" smtClean="0"/>
+              <a:rPr lang="en-US"/>
               <a:t>Fourth level</a:t>
             </a:r>
           </a:p>
           <a:p>
             <a:pPr lvl="4"/>
             <a:r>
-              <a:rPr lang="en-US" smtClean="0"/>
+              <a:rPr lang="en-US"/>
               <a:t>Fifth level</a:t>
             </a:r>
-            <a:endParaRPr lang="en-US"/>
           </a:p>
         </p:txBody>
       </p:sp>
@@ -645,7 +847,7 @@
           <a:p>
             <a:fld id="{5BCAD085-E8A6-8845-BD4E-CB4CCA059FC4}" type="datetimeFigureOut">
               <a:rPr lang="en-US" smtClean="0"/>
-              <a:t>1/27/13</a:t>
+              <a:t>8/10/26</a:t>
             </a:fld>
             <a:endParaRPr lang="en-US"/>
           </a:p>
@@ -744,10 +946,9 @@
           <a:lstStyle/>
           <a:p>
             <a:r>
-              <a:rPr lang="en-US" smtClean="0"/>
+              <a:rPr lang="en-US"/>
               <a:t>Click to edit Master title style</a:t>
             </a:r>
-            <a:endParaRPr lang="en-US"/>
           </a:p>
         </p:txBody>
       </p:sp>
@@ -773,38 +974,37 @@
           <a:p>
             <a:pPr lvl="0"/>
             <a:r>
-              <a:rPr lang="en-US" smtClean="0"/>
+              <a:rPr lang="en-US"/>
               <a:t>Click to edit Master text styles</a:t>
             </a:r>
           </a:p>
           <a:p>
             <a:pPr lvl="1"/>
             <a:r>
-              <a:rPr lang="en-US" smtClean="0"/>
+              <a:rPr lang="en-US"/>
               <a:t>Second level</a:t>
             </a:r>
           </a:p>
           <a:p>
             <a:pPr lvl="2"/>
             <a:r>
-              <a:rPr lang="en-US" smtClean="0"/>
+              <a:rPr lang="en-US"/>
               <a:t>Third level</a:t>
             </a:r>
           </a:p>
           <a:p>
             <a:pPr lvl="3"/>
             <a:r>
-              <a:rPr lang="en-US" smtClean="0"/>
+              <a:rPr lang="en-US"/>
               <a:t>Fourth level</a:t>
             </a:r>
           </a:p>
           <a:p>
             <a:pPr lvl="4"/>
             <a:r>
-              <a:rPr lang="en-US" smtClean="0"/>
+              <a:rPr lang="en-US"/>
               <a:t>Fifth level</a:t>
             </a:r>
-            <a:endParaRPr lang="en-US"/>
           </a:p>
         </p:txBody>
       </p:sp>
@@ -825,7 +1025,7 @@
           <a:p>
             <a:fld id="{5BCAD085-E8A6-8845-BD4E-CB4CCA059FC4}" type="datetimeFigureOut">
               <a:rPr lang="en-US" smtClean="0"/>
-              <a:t>1/27/13</a:t>
+              <a:t>8/10/26</a:t>
             </a:fld>
             <a:endParaRPr lang="en-US"/>
           </a:p>
@@ -919,10 +1119,9 @@
           <a:lstStyle/>
           <a:p>
             <a:r>
-              <a:rPr lang="en-US" smtClean="0"/>
+              <a:rPr lang="en-US"/>
               <a:t>Click to edit Master title style</a:t>
             </a:r>
-            <a:endParaRPr lang="en-US"/>
           </a:p>
         </p:txBody>
       </p:sp>
@@ -943,38 +1142,37 @@
           <a:p>
             <a:pPr lvl="0"/>
             <a:r>
-              <a:rPr lang="en-US" smtClean="0"/>
+              <a:rPr lang="en-US"/>
               <a:t>Click to edit Master text styles</a:t>
             </a:r>
           </a:p>
           <a:p>
             <a:pPr lvl="1"/>
             <a:r>
-              <a:rPr lang="en-US" smtClean="0"/>
+              <a:rPr lang="en-US"/>
               <a:t>Second level</a:t>
             </a:r>
           </a:p>
           <a:p>
             <a:pPr lvl="2"/>
             <a:r>
-              <a:rPr lang="en-US" smtClean="0"/>
+              <a:rPr lang="en-US"/>
               <a:t>Third level</a:t>
             </a:r>
           </a:p>
           <a:p>
             <a:pPr lvl="3"/>
             <a:r>
-              <a:rPr lang="en-US" smtClean="0"/>
+              <a:rPr lang="en-US"/>
               <a:t>Fourth level</a:t>
             </a:r>
           </a:p>
           <a:p>
             <a:pPr lvl="4"/>
             <a:r>
-              <a:rPr lang="en-US" smtClean="0"/>
+              <a:rPr lang="en-US"/>
               <a:t>Fifth level</a:t>
             </a:r>
-            <a:endParaRPr lang="en-US"/>
           </a:p>
         </p:txBody>
       </p:sp>
@@ -995,7 +1193,7 @@
           <a:p>
             <a:fld id="{5BCAD085-E8A6-8845-BD4E-CB4CCA059FC4}" type="datetimeFigureOut">
               <a:rPr lang="en-US" smtClean="0"/>
-              <a:t>1/27/13</a:t>
+              <a:t>8/10/26</a:t>
             </a:fld>
             <a:endParaRPr lang="en-US"/>
           </a:p>
@@ -1098,10 +1296,9 @@
           </a:lstStyle>
           <a:p>
             <a:r>
-              <a:rPr lang="en-US" smtClean="0"/>
+              <a:rPr lang="en-US"/>
               <a:t>Click to edit Master title style</a:t>
             </a:r>
-            <a:endParaRPr lang="en-US"/>
           </a:p>
         </p:txBody>
       </p:sp>
@@ -1218,7 +1415,7 @@
           <a:p>
             <a:pPr lvl="0"/>
             <a:r>
-              <a:rPr lang="en-US" smtClean="0"/>
+              <a:rPr lang="en-US"/>
               <a:t>Click to edit Master text styles</a:t>
             </a:r>
           </a:p>
@@ -1241,7 +1438,7 @@
           <a:p>
             <a:fld id="{5BCAD085-E8A6-8845-BD4E-CB4CCA059FC4}" type="datetimeFigureOut">
               <a:rPr lang="en-US" smtClean="0"/>
-              <a:t>1/27/13</a:t>
+              <a:t>8/10/26</a:t>
             </a:fld>
             <a:endParaRPr lang="en-US"/>
           </a:p>
@@ -1335,10 +1532,9 @@
           <a:lstStyle/>
           <a:p>
             <a:r>
-              <a:rPr lang="en-US" smtClean="0"/>
+              <a:rPr lang="en-US"/>
               <a:t>Click to edit Master title style</a:t>
             </a:r>
-            <a:endParaRPr lang="en-US"/>
           </a:p>
         </p:txBody>
       </p:sp>
@@ -1392,38 +1588,37 @@
           <a:p>
             <a:pPr lvl="0"/>
             <a:r>
-              <a:rPr lang="en-US" smtClean="0"/>
+              <a:rPr lang="en-US"/>
               <a:t>Click to edit Master text styles</a:t>
             </a:r>
           </a:p>
           <a:p>
             <a:pPr lvl="1"/>
             <a:r>
-              <a:rPr lang="en-US" smtClean="0"/>
+              <a:rPr lang="en-US"/>
               <a:t>Second level</a:t>
             </a:r>
           </a:p>
           <a:p>
             <a:pPr lvl="2"/>
             <a:r>
-              <a:rPr lang="en-US" smtClean="0"/>
+              <a:rPr lang="en-US"/>
               <a:t>Third level</a:t>
             </a:r>
           </a:p>
           <a:p>
             <a:pPr lvl="3"/>
             <a:r>
-              <a:rPr lang="en-US" smtClean="0"/>
+              <a:rPr lang="en-US"/>
               <a:t>Fourth level</a:t>
             </a:r>
           </a:p>
           <a:p>
             <a:pPr lvl="4"/>
             <a:r>
-              <a:rPr lang="en-US" smtClean="0"/>
+              <a:rPr lang="en-US"/>
               <a:t>Fifth level</a:t>
             </a:r>
-            <a:endParaRPr lang="en-US"/>
           </a:p>
         </p:txBody>
       </p:sp>
@@ -1477,38 +1672,37 @@
           <a:p>
             <a:pPr lvl="0"/>
             <a:r>
-              <a:rPr lang="en-US" smtClean="0"/>
+              <a:rPr lang="en-US"/>
               <a:t>Click to edit Master text styles</a:t>
             </a:r>
           </a:p>
           <a:p>
             <a:pPr lvl="1"/>
             <a:r>
-              <a:rPr lang="en-US" smtClean="0"/>
+              <a:rPr lang="en-US"/>
               <a:t>Second level</a:t>
             </a:r>
           </a:p>
           <a:p>
             <a:pPr lvl="2"/>
             <a:r>
-              <a:rPr lang="en-US" smtClean="0"/>
+              <a:rPr lang="en-US"/>
               <a:t>Third level</a:t>
             </a:r>
           </a:p>
           <a:p>
             <a:pPr lvl="3"/>
             <a:r>
-              <a:rPr lang="en-US" smtClean="0"/>
+              <a:rPr lang="en-US"/>
               <a:t>Fourth level</a:t>
             </a:r>
           </a:p>
           <a:p>
             <a:pPr lvl="4"/>
             <a:r>
-              <a:rPr lang="en-US" smtClean="0"/>
+              <a:rPr lang="en-US"/>
               <a:t>Fifth level</a:t>
             </a:r>
-            <a:endParaRPr lang="en-US"/>
           </a:p>
         </p:txBody>
       </p:sp>
@@ -1529,7 +1723,7 @@
           <a:p>
             <a:fld id="{5BCAD085-E8A6-8845-BD4E-CB4CCA059FC4}" type="datetimeFigureOut">
               <a:rPr lang="en-US" smtClean="0"/>
-              <a:t>1/27/13</a:t>
+              <a:t>8/10/26</a:t>
             </a:fld>
             <a:endParaRPr lang="en-US"/>
           </a:p>
@@ -1627,10 +1821,9 @@
           </a:lstStyle>
           <a:p>
             <a:r>
-              <a:rPr lang="en-US" smtClean="0"/>
+              <a:rPr lang="en-US"/>
               <a:t>Click to edit Master title style</a:t>
             </a:r>
-            <a:endParaRPr lang="en-US"/>
           </a:p>
         </p:txBody>
       </p:sp>
@@ -1693,7 +1886,7 @@
           <a:p>
             <a:pPr lvl="0"/>
             <a:r>
-              <a:rPr lang="en-US" smtClean="0"/>
+              <a:rPr lang="en-US"/>
               <a:t>Click to edit Master text styles</a:t>
             </a:r>
           </a:p>
@@ -1749,38 +1942,37 @@
           <a:p>
             <a:pPr lvl="0"/>
             <a:r>
-              <a:rPr lang="en-US" smtClean="0"/>
+              <a:rPr lang="en-US"/>
               <a:t>Click to edit Master text styles</a:t>
             </a:r>
           </a:p>
           <a:p>
             <a:pPr lvl="1"/>
             <a:r>
-              <a:rPr lang="en-US" smtClean="0"/>
+              <a:rPr lang="en-US"/>
               <a:t>Second level</a:t>
             </a:r>
           </a:p>
           <a:p>
             <a:pPr lvl="2"/>
             <a:r>
-              <a:rPr lang="en-US" smtClean="0"/>
+              <a:rPr lang="en-US"/>
               <a:t>Third level</a:t>
             </a:r>
           </a:p>
           <a:p>
             <a:pPr lvl="3"/>
             <a:r>
-              <a:rPr lang="en-US" smtClean="0"/>
+              <a:rPr lang="en-US"/>
               <a:t>Fourth level</a:t>
             </a:r>
           </a:p>
           <a:p>
             <a:pPr lvl="4"/>
             <a:r>
-              <a:rPr lang="en-US" smtClean="0"/>
+              <a:rPr lang="en-US"/>
               <a:t>Fifth level</a:t>
             </a:r>
-            <a:endParaRPr lang="en-US"/>
           </a:p>
         </p:txBody>
       </p:sp>
@@ -1843,7 +2035,7 @@
           <a:p>
             <a:pPr lvl="0"/>
             <a:r>
-              <a:rPr lang="en-US" smtClean="0"/>
+              <a:rPr lang="en-US"/>
               <a:t>Click to edit Master text styles</a:t>
             </a:r>
           </a:p>
@@ -1899,38 +2091,37 @@
           <a:p>
             <a:pPr lvl="0"/>
             <a:r>
-              <a:rPr lang="en-US" smtClean="0"/>
+              <a:rPr lang="en-US"/>
               <a:t>Click to edit Master text styles</a:t>
             </a:r>
           </a:p>
           <a:p>
             <a:pPr lvl="1"/>
             <a:r>
-              <a:rPr lang="en-US" smtClean="0"/>
+              <a:rPr lang="en-US"/>
               <a:t>Second level</a:t>
             </a:r>
           </a:p>
           <a:p>
             <a:pPr lvl="2"/>
             <a:r>
-              <a:rPr lang="en-US" smtClean="0"/>
+              <a:rPr lang="en-US"/>
               <a:t>Third level</a:t>
             </a:r>
           </a:p>
           <a:p>
             <a:pPr lvl="3"/>
             <a:r>
-              <a:rPr lang="en-US" smtClean="0"/>
+              <a:rPr lang="en-US"/>
               <a:t>Fourth level</a:t>
             </a:r>
           </a:p>
           <a:p>
             <a:pPr lvl="4"/>
             <a:r>
-              <a:rPr lang="en-US" smtClean="0"/>
+              <a:rPr lang="en-US"/>
               <a:t>Fifth level</a:t>
             </a:r>
-            <a:endParaRPr lang="en-US"/>
           </a:p>
         </p:txBody>
       </p:sp>
@@ -1951,7 +2142,7 @@
           <a:p>
             <a:fld id="{5BCAD085-E8A6-8845-BD4E-CB4CCA059FC4}" type="datetimeFigureOut">
               <a:rPr lang="en-US" smtClean="0"/>
-              <a:t>1/27/13</a:t>
+              <a:t>8/10/26</a:t>
             </a:fld>
             <a:endParaRPr lang="en-US"/>
           </a:p>
@@ -2045,10 +2236,9 @@
           <a:lstStyle/>
           <a:p>
             <a:r>
-              <a:rPr lang="en-US" smtClean="0"/>
+              <a:rPr lang="en-US"/>
               <a:t>Click to edit Master title style</a:t>
             </a:r>
-            <a:endParaRPr lang="en-US"/>
           </a:p>
         </p:txBody>
       </p:sp>
@@ -2069,7 +2259,7 @@
           <a:p>
             <a:fld id="{5BCAD085-E8A6-8845-BD4E-CB4CCA059FC4}" type="datetimeFigureOut">
               <a:rPr lang="en-US" smtClean="0"/>
-              <a:t>1/27/13</a:t>
+              <a:t>8/10/26</a:t>
             </a:fld>
             <a:endParaRPr lang="en-US"/>
           </a:p>
@@ -2164,7 +2354,7 @@
           <a:p>
             <a:fld id="{5BCAD085-E8A6-8845-BD4E-CB4CCA059FC4}" type="datetimeFigureOut">
               <a:rPr lang="en-US" smtClean="0"/>
-              <a:t>1/27/13</a:t>
+              <a:t>8/10/26</a:t>
             </a:fld>
             <a:endParaRPr lang="en-US"/>
           </a:p>
@@ -2267,10 +2457,9 @@
           </a:lstStyle>
           <a:p>
             <a:r>
-              <a:rPr lang="en-US" smtClean="0"/>
+              <a:rPr lang="en-US"/>
               <a:t>Click to edit Master title style</a:t>
             </a:r>
-            <a:endParaRPr lang="en-US"/>
           </a:p>
         </p:txBody>
       </p:sp>
@@ -2324,38 +2513,37 @@
           <a:p>
             <a:pPr lvl="0"/>
             <a:r>
-              <a:rPr lang="en-US" smtClean="0"/>
+              <a:rPr lang="en-US"/>
               <a:t>Click to edit Master text styles</a:t>
             </a:r>
           </a:p>
           <a:p>
             <a:pPr lvl="1"/>
             <a:r>
-              <a:rPr lang="en-US" smtClean="0"/>
+              <a:rPr lang="en-US"/>
               <a:t>Second level</a:t>
             </a:r>
           </a:p>
           <a:p>
             <a:pPr lvl="2"/>
             <a:r>
-              <a:rPr lang="en-US" smtClean="0"/>
+              <a:rPr lang="en-US"/>
               <a:t>Third level</a:t>
             </a:r>
           </a:p>
           <a:p>
             <a:pPr lvl="3"/>
             <a:r>
-              <a:rPr lang="en-US" smtClean="0"/>
+              <a:rPr lang="en-US"/>
               <a:t>Fourth level</a:t>
             </a:r>
           </a:p>
           <a:p>
             <a:pPr lvl="4"/>
             <a:r>
-              <a:rPr lang="en-US" smtClean="0"/>
+              <a:rPr lang="en-US"/>
               <a:t>Fifth level</a:t>
             </a:r>
-            <a:endParaRPr lang="en-US"/>
           </a:p>
         </p:txBody>
       </p:sp>
@@ -2418,7 +2606,7 @@
           <a:p>
             <a:pPr lvl="0"/>
             <a:r>
-              <a:rPr lang="en-US" smtClean="0"/>
+              <a:rPr lang="en-US"/>
               <a:t>Click to edit Master text styles</a:t>
             </a:r>
           </a:p>
@@ -2441,7 +2629,7 @@
           <a:p>
             <a:fld id="{5BCAD085-E8A6-8845-BD4E-CB4CCA059FC4}" type="datetimeFigureOut">
               <a:rPr lang="en-US" smtClean="0"/>
-              <a:t>1/27/13</a:t>
+              <a:t>8/10/26</a:t>
             </a:fld>
             <a:endParaRPr lang="en-US"/>
           </a:p>
@@ -2544,10 +2732,9 @@
           </a:lstStyle>
           <a:p>
             <a:r>
-              <a:rPr lang="en-US" smtClean="0"/>
+              <a:rPr lang="en-US"/>
               <a:t>Click to edit Master title style</a:t>
             </a:r>
-            <a:endParaRPr lang="en-US"/>
           </a:p>
         </p:txBody>
       </p:sp>
@@ -2671,7 +2858,7 @@
           <a:p>
             <a:pPr lvl="0"/>
             <a:r>
-              <a:rPr lang="en-US" smtClean="0"/>
+              <a:rPr lang="en-US"/>
               <a:t>Click to edit Master text styles</a:t>
             </a:r>
           </a:p>
@@ -2694,7 +2881,7 @@
           <a:p>
             <a:fld id="{5BCAD085-E8A6-8845-BD4E-CB4CCA059FC4}" type="datetimeFigureOut">
               <a:rPr lang="en-US" smtClean="0"/>
-              <a:t>1/27/13</a:t>
+              <a:t>8/10/26</a:t>
             </a:fld>
             <a:endParaRPr lang="en-US"/>
           </a:p>
@@ -2803,10 +2990,9 @@
           <a:lstStyle/>
           <a:p>
             <a:r>
-              <a:rPr lang="en-US" smtClean="0"/>
+              <a:rPr lang="en-US"/>
               <a:t>Click to edit Master title style</a:t>
             </a:r>
-            <a:endParaRPr lang="en-US"/>
           </a:p>
         </p:txBody>
       </p:sp>
@@ -2837,38 +3023,37 @@
           <a:p>
             <a:pPr lvl="0"/>
             <a:r>
-              <a:rPr lang="en-US" smtClean="0"/>
+              <a:rPr lang="en-US"/>
               <a:t>Click to edit Master text styles</a:t>
             </a:r>
           </a:p>
           <a:p>
             <a:pPr lvl="1"/>
             <a:r>
-              <a:rPr lang="en-US" smtClean="0"/>
+              <a:rPr lang="en-US"/>
               <a:t>Second level</a:t>
             </a:r>
           </a:p>
           <a:p>
             <a:pPr lvl="2"/>
             <a:r>
-              <a:rPr lang="en-US" smtClean="0"/>
+              <a:rPr lang="en-US"/>
               <a:t>Third level</a:t>
             </a:r>
           </a:p>
           <a:p>
             <a:pPr lvl="3"/>
             <a:r>
-              <a:rPr lang="en-US" smtClean="0"/>
+              <a:rPr lang="en-US"/>
               <a:t>Fourth level</a:t>
             </a:r>
           </a:p>
           <a:p>
             <a:pPr lvl="4"/>
             <a:r>
-              <a:rPr lang="en-US" smtClean="0"/>
+              <a:rPr lang="en-US"/>
               <a:t>Fifth level</a:t>
             </a:r>
-            <a:endParaRPr lang="en-US"/>
           </a:p>
         </p:txBody>
       </p:sp>
@@ -2907,7 +3092,7 @@
           <a:p>
             <a:fld id="{5BCAD085-E8A6-8845-BD4E-CB4CCA059FC4}" type="datetimeFigureOut">
               <a:rPr lang="en-US" smtClean="0"/>
-              <a:t>1/27/13</a:t>
+              <a:t>8/10/26</a:t>
             </a:fld>
             <a:endParaRPr lang="en-US"/>
           </a:p>
@@ -3266,7 +3451,7 @@
 </file>
 
 <file path=ppt/slides/slide1.xml><?xml version="1.0" encoding="utf-8"?>
-<p:sld xmlns:a="http://schemas.openxmlformats.org/drawingml/2006/main" xmlns:p="http://schemas.openxmlformats.org/presentationml/2006/main" xmlns:r="http://schemas.openxmlformats.org/officeDocument/2006/relationships">
+<p:sld xmlns:a="http://schemas.openxmlformats.org/drawingml/2006/main" xmlns:r="http://schemas.openxmlformats.org/officeDocument/2006/relationships" xmlns:p="http://schemas.openxmlformats.org/presentationml/2006/main">
   <p:cSld>
     <p:spTree>
       <p:nvGrpSpPr>
@@ -3274,7 +3459,14 @@
         <p:cNvGrpSpPr/>
         <p:nvPr/>
       </p:nvGrpSpPr>
-      <p:grpSpPr/>
+      <p:grpSpPr>
+        <a:xfrm>
+          <a:off x="0" y="0"/>
+          <a:ext cx="0" cy="0"/>
+          <a:chOff x="0" y="0"/>
+          <a:chExt cx="0" cy="0"/>
+        </a:xfrm>
+      </p:grpSpPr>
       <p:sp>
         <p:nvSpPr>
           <p:cNvPr id="2" name="Title 1"/>
@@ -3310,7 +3502,71 @@
         </p:xfrm>
         <a:graphic>
           <a:graphicData uri="http://schemas.openxmlformats.org/drawingml/2006/chart">
-            <c:chart xmlns:c="http://schemas.openxmlformats.org/drawingml/2006/chart" r:id="rId2"/>
+            <c:chart xmlns:c="http://schemas.openxmlformats.org/drawingml/2006/chart" xmlns:r="http://schemas.openxmlformats.org/officeDocument/2006/relationships" r:id="rId2"/>
+          </a:graphicData>
+        </a:graphic>
+      </p:graphicFrame>
+    </p:spTree>
+  </p:cSld>
+  <p:clrMapOvr>
+    <a:masterClrMapping/>
+  </p:clrMapOvr>
+</p:sld>
+</file>
+
+<file path=ppt/slides/slide2.xml><?xml version="1.0" encoding="utf-8"?>
+<p:sld xmlns:a="http://schemas.openxmlformats.org/drawingml/2006/main" xmlns:r="http://schemas.openxmlformats.org/officeDocument/2006/relationships" xmlns:p="http://schemas.openxmlformats.org/presentationml/2006/main">
+  <p:cSld>
+    <p:spTree>
+      <p:nvGrpSpPr>
+        <p:cNvPr id="1" name=""/>
+        <p:cNvGrpSpPr/>
+        <p:nvPr/>
+      </p:nvGrpSpPr>
+      <p:grpSpPr>
+        <a:xfrm>
+          <a:off x="0" y="0"/>
+          <a:ext cx="0" cy="0"/>
+          <a:chOff x="0" y="0"/>
+          <a:chExt cx="0" cy="0"/>
+        </a:xfrm>
+      </p:grpSpPr>
+      <p:sp>
+        <p:nvSpPr>
+          <p:cNvPr id="2" name="Title 1"/>
+          <p:cNvSpPr>
+            <a:spLocks noGrp="1"/>
+          </p:cNvSpPr>
+          <p:nvPr>
+            <p:ph type="title"/>
+          </p:nvPr>
+        </p:nvSpPr>
+        <p:spPr/>
+        <p:txBody>
+          <a:bodyPr/>
+          <a:lstStyle/>
+          <a:p>
+            <a:r>
+              <a:t>Quarterly revenue</a:t>
+            </a:r>
+          </a:p>
+        </p:txBody>
+      </p:sp>
+      <p:graphicFrame>
+        <p:nvGraphicFramePr>
+          <p:cNvPr id="3" name="Chart 2"/>
+          <p:cNvGraphicFramePr>
+            <a:graphicFrameLocks noGrp="1"/>
+          </p:cNvGraphicFramePr>
+          <p:nvPr/>
+        </p:nvGraphicFramePr>
+        <p:xfrm>
+          <a:off x="914400" y="1828800"/>
+          <a:ext cx="5486400" cy="3657600"/>
+        </p:xfrm>
+        <a:graphic>
+          <a:graphicData uri="http://schemas.openxmlformats.org/drawingml/2006/chart">
+            <c:chart xmlns:c="http://schemas.openxmlformats.org/drawingml/2006/chart" xmlns:r="http://schemas.openxmlformats.org/officeDocument/2006/relationships" r:id="rId2"/>
           </a:graphicData>
         </a:graphic>
       </p:graphicFrame>

</xml_diff>